<commit_message>
Fix live incident matching and graph visibility
</commit_message>
<xml_diff>
--- a/deliverables/Farms_for_Food_pitch_deck.pptx
+++ b/deliverables/Farms_for_Food_pitch_deck.pptx
@@ -841,7 +841,7 @@
           <a:p>
             <a:r>
               <a:rPr lang="en-US" dirty="0"/>
-              <a:t>Farms for Food is a decision-support command center for food-bank recall response. Current openFDA and USDA FSIS incidents enter through official APIs, while inventory, purchase orders, demand, and recovery offers remain synthetic. The system ends at a human approval gate and exposes no action when an authority incident has no linked lot or purchase order.</a:t>
+              <a:t>Farms for Food is a decision-support command center for food-bank recall response. Current openFDA and USDA FSIS incidents enter through official APIs, while inventory, purchase orders, demand, and recovery offers remain synthetic. Live records expose two explicit modes: a visibly prefixed SYN-LIVE trace sample for inspecting matches, or the untouched seed network for an honest zero-exposure check. Every action still stops at human review.</a:t>
             </a:r>
             <a:endParaRPr lang="en-US" dirty="0"/>
           </a:p>
@@ -1193,7 +1193,7 @@
           <a:p>
             <a:r>
               <a:rPr lang="en-US" dirty="0"/>
-              <a:t>These source-evidence pairs come from the public deterministic positive-exposure replay and are enlarged so the provenance contract is inspectable in the room. Current openFDA and USDA FSIS records retain the same field-level provenance, authority warning, retrieval time, and source link. If no synthetic lot or purchase order joins to a real incident, Farms for Food presents an explicit no-exposure result instead of manufacturing a recovery action.</a:t>
+              <a:t>These source-evidence pairs come from the public deterministic positive-exposure replay and are enlarged so the provenance contract is inspectable in the room. Current openFDA and USDA FSIS records retain the same field-level provenance, authority warning, retrieval time, and source link. The default SYN-LIVE trace sample copies only source-supported identifiers into visibly synthetic records; switching it off checks the untouched seed network and presents an explicit no-exposure result when nothing joins.</a:t>
             </a:r>
             <a:endParaRPr lang="en-US" dirty="0"/>
           </a:p>
@@ -1693,7 +1693,7 @@
               <a:buNone/>
             </a:pPr>
             <a:r>
-              <a:rPr lang="en-US" sz="1000" b="1" dirty="0">
+              <a:rPr lang="en-US" sz="850" b="1" dirty="0">
                 <a:solidFill>
                   <a:srgbClr val="FFFDF8"/>
                 </a:solidFill>
@@ -1701,9 +1701,9 @@
                 <a:ea typeface="Aptos" pitchFamily="34" charset="-122"/>
                 <a:cs typeface="Aptos" pitchFamily="34" charset="-120"/>
               </a:rPr>
-              <a:t>FF</a:t>
-            </a:r>
-            <a:endParaRPr lang="en-US" sz="1000" dirty="0"/>
+              <a:t>FFF</a:t>
+            </a:r>
+            <a:endParaRPr lang="en-US" sz="850" dirty="0"/>
           </a:p>
         </p:txBody>
       </p:sp>
@@ -2256,7 +2256,7 @@
               <a:buNone/>
             </a:pPr>
             <a:r>
-              <a:rPr lang="en-US" sz="1100" b="1" dirty="0">
+              <a:rPr lang="en-US" sz="1000" b="1" dirty="0">
                 <a:solidFill>
                   <a:srgbClr val="FFFDF8"/>
                 </a:solidFill>
@@ -2264,9 +2264,9 @@
                 <a:ea typeface="Aptos" pitchFamily="34" charset="-122"/>
                 <a:cs typeface="Aptos" pitchFamily="34" charset="-120"/>
               </a:rPr>
-              <a:t>FF</a:t>
-            </a:r>
-            <a:endParaRPr lang="en-US" sz="1100" dirty="0"/>
+              <a:t>FFF</a:t>
+            </a:r>
+            <a:endParaRPr lang="en-US" sz="1000" dirty="0"/>
           </a:p>
         </p:txBody>
       </p:sp>
@@ -2419,7 +2419,7 @@
         <p:spPr>
           <a:xfrm>
             <a:off x="658368" y="3456432"/>
-            <a:ext cx="5989320" cy="914400"/>
+            <a:ext cx="6309360" cy="914400"/>
           </a:xfrm>
           <a:prstGeom prst="rect">
             <a:avLst/>
@@ -2445,7 +2445,7 @@
                 <a:ea typeface="Aptos" pitchFamily="34" charset="-122"/>
                 <a:cs typeface="Aptos" pitchFamily="34" charset="-120"/>
               </a:rPr>
-              <a:t>Trace implicated lots and inbound orders, quantify seven-day supply risk, then optimize a feasible response before anything executes.</a:t>
+              <a:t>Trace implicated lots and inbound orders, quantify 7-day supply risk, then optimize a feasible response before anything executes.</a:t>
             </a:r>
             <a:endParaRPr lang="en-US" sz="1800" dirty="0"/>
           </a:p>
@@ -2587,9 +2587,9 @@
               <a:buNone/>
             </a:pPr>
             <a:r>
-              <a:rPr lang="en-US" sz="850" dirty="0">
-                <a:solidFill>
-                  <a:srgbClr val="78B7A9"/>
+              <a:rPr lang="en-US" sz="900" dirty="0">
+                <a:solidFill>
+                  <a:srgbClr val="D7E7E1"/>
                 </a:solidFill>
                 <a:latin typeface="Aptos" pitchFamily="34" charset="0"/>
                 <a:ea typeface="Aptos" pitchFamily="34" charset="-122"/>
@@ -2597,7 +2597,7 @@
               </a:rPr>
               <a:t>live authority</a:t>
             </a:r>
-            <a:endParaRPr lang="en-US" sz="850" dirty="0"/>
+            <a:endParaRPr lang="en-US" sz="900" dirty="0"/>
           </a:p>
         </p:txBody>
       </p:sp>
@@ -2762,9 +2762,9 @@
               <a:buNone/>
             </a:pPr>
             <a:r>
-              <a:rPr lang="en-US" sz="850" dirty="0">
-                <a:solidFill>
-                  <a:srgbClr val="78B7A9"/>
+              <a:rPr lang="en-US" sz="900" dirty="0">
+                <a:solidFill>
+                  <a:srgbClr val="D7E7E1"/>
                 </a:solidFill>
                 <a:latin typeface="Aptos" pitchFamily="34" charset="0"/>
                 <a:ea typeface="Aptos" pitchFamily="34" charset="-122"/>
@@ -2772,7 +2772,7 @@
               </a:rPr>
               <a:t>lots + POs</a:t>
             </a:r>
-            <a:endParaRPr lang="en-US" sz="850" dirty="0"/>
+            <a:endParaRPr lang="en-US" sz="900" dirty="0"/>
           </a:p>
         </p:txBody>
       </p:sp>
@@ -2937,9 +2937,9 @@
               <a:buNone/>
             </a:pPr>
             <a:r>
-              <a:rPr lang="en-US" sz="850" dirty="0">
-                <a:solidFill>
-                  <a:srgbClr val="78B7A9"/>
+              <a:rPr lang="en-US" sz="900" dirty="0">
+                <a:solidFill>
+                  <a:srgbClr val="D7E7E1"/>
                 </a:solidFill>
                 <a:latin typeface="Aptos" pitchFamily="34" charset="0"/>
                 <a:ea typeface="Aptos" pitchFamily="34" charset="-122"/>
@@ -2947,7 +2947,7 @@
               </a:rPr>
               <a:t>LP + FEFO</a:t>
             </a:r>
-            <a:endParaRPr lang="en-US" sz="850" dirty="0"/>
+            <a:endParaRPr lang="en-US" sz="900" dirty="0"/>
           </a:p>
         </p:txBody>
       </p:sp>
@@ -3112,9 +3112,9 @@
               <a:buNone/>
             </a:pPr>
             <a:r>
-              <a:rPr lang="en-US" sz="850" dirty="0">
-                <a:solidFill>
-                  <a:srgbClr val="78B7A9"/>
+              <a:rPr lang="en-US" sz="900" dirty="0">
+                <a:solidFill>
+                  <a:srgbClr val="D7E7E1"/>
                 </a:solidFill>
                 <a:latin typeface="Aptos" pitchFamily="34" charset="0"/>
                 <a:ea typeface="Aptos" pitchFamily="34" charset="-122"/>
@@ -3122,7 +3122,7 @@
               </a:rPr>
               <a:t>human gate</a:t>
             </a:r>
-            <a:endParaRPr lang="en-US" sz="850" dirty="0"/>
+            <a:endParaRPr lang="en-US" sz="900" dirty="0"/>
           </a:p>
         </p:txBody>
       </p:sp>
@@ -3794,9 +3794,9 @@
               <a:buNone/>
             </a:pPr>
             <a:r>
-              <a:rPr lang="en-US" sz="900" dirty="0">
-                <a:solidFill>
-                  <a:srgbClr val="78B7A9"/>
+              <a:rPr lang="en-US" sz="950" dirty="0">
+                <a:solidFill>
+                  <a:srgbClr val="D7E7E1"/>
                 </a:solidFill>
                 <a:latin typeface="Aptos" pitchFamily="34" charset="0"/>
                 <a:ea typeface="Aptos" pitchFamily="34" charset="-122"/>
@@ -3804,7 +3804,7 @@
               </a:rPr>
               <a:t>Live FDA/USDA incidents. Synthetic food-bank operations. No client PII.</a:t>
             </a:r>
-            <a:endParaRPr lang="en-US" sz="900" dirty="0"/>
+            <a:endParaRPr lang="en-US" sz="950" dirty="0"/>
           </a:p>
         </p:txBody>
       </p:sp>
@@ -3991,7 +3991,7 @@
                 <a:ea typeface="Aptos" pitchFamily="34" charset="-122"/>
                 <a:cs typeface="Aptos" pitchFamily="34" charset="-120"/>
               </a:rPr>
-              <a:t>Public 2024 records show the scale. A single contaminated ingredient can intersect a perishable, high-throughput food-bank network.</a:t>
+              <a:t>Public 2024 records show the scale. A single contaminated ingredient can intersect a perishable, high-throughput food bank network.</a:t>
             </a:r>
             <a:endParaRPr lang="en-US" sz="1600" dirty="0"/>
           </a:p>
@@ -5143,7 +5143,7 @@
               <a:buNone/>
             </a:pPr>
             <a:r>
-              <a:rPr lang="en-US" sz="850" dirty="0">
+              <a:rPr lang="en-US" sz="900" dirty="0">
                 <a:solidFill>
                   <a:srgbClr val="61706D"/>
                 </a:solidFill>
@@ -5157,7 +5157,7 @@
               <a:buNone/>
             </a:pPr>
             <a:r>
-              <a:rPr lang="en-US" sz="850" u="sng" dirty="0">
+              <a:rPr lang="en-US" sz="900" u="sng" dirty="0">
                 <a:solidFill>
                   <a:srgbClr val="1D6B62"/>
                 </a:solidFill>
@@ -5183,7 +5183,7 @@
               <a:buNone/>
             </a:pPr>
             <a:r>
-              <a:rPr lang="en-US" sz="850" dirty="0">
+              <a:rPr lang="en-US" sz="900" dirty="0">
                 <a:solidFill>
                   <a:srgbClr val="D9D2C2"/>
                 </a:solidFill>
@@ -5197,7 +5197,7 @@
               <a:buNone/>
             </a:pPr>
             <a:r>
-              <a:rPr lang="en-US" sz="850" u="sng" dirty="0">
+              <a:rPr lang="en-US" sz="900" u="sng" dirty="0">
                 <a:solidFill>
                   <a:srgbClr val="1D6B62"/>
                 </a:solidFill>
@@ -5223,7 +5223,7 @@
               <a:buNone/>
             </a:pPr>
             <a:r>
-              <a:rPr lang="en-US" sz="850" dirty="0">
+              <a:rPr lang="en-US" sz="900" dirty="0">
                 <a:solidFill>
                   <a:srgbClr val="D9D2C2"/>
                 </a:solidFill>
@@ -5237,7 +5237,7 @@
               <a:buNone/>
             </a:pPr>
             <a:r>
-              <a:rPr lang="en-US" sz="850" u="sng" dirty="0">
+              <a:rPr lang="en-US" sz="900" u="sng" dirty="0">
                 <a:solidFill>
                   <a:srgbClr val="1D6B62"/>
                 </a:solidFill>
@@ -5263,7 +5263,7 @@
               <a:buNone/>
             </a:pPr>
             <a:r>
-              <a:rPr lang="en-US" sz="850" dirty="0">
+              <a:rPr lang="en-US" sz="900" dirty="0">
                 <a:solidFill>
                   <a:srgbClr val="D9D2C2"/>
                 </a:solidFill>
@@ -5277,7 +5277,7 @@
               <a:buNone/>
             </a:pPr>
             <a:r>
-              <a:rPr lang="en-US" sz="850" u="sng" dirty="0">
+              <a:rPr lang="en-US" sz="900" u="sng" dirty="0">
                 <a:solidFill>
                   <a:srgbClr val="1D6B62"/>
                 </a:solidFill>
@@ -5299,7 +5299,7 @@
               </a:rPr>
               <a:t>SF-Marin Food Bank FY2024</a:t>
             </a:r>
-            <a:endParaRPr lang="en-US" sz="850" dirty="0"/>
+            <a:endParaRPr lang="en-US" sz="900" dirty="0"/>
           </a:p>
         </p:txBody>
       </p:sp>
@@ -6883,7 +6883,7 @@
               <a:buNone/>
             </a:pPr>
             <a:r>
-              <a:rPr lang="en-US" sz="850" dirty="0">
+              <a:rPr lang="en-US" sz="900" dirty="0">
                 <a:solidFill>
                   <a:srgbClr val="61706D"/>
                 </a:solidFill>
@@ -6897,7 +6897,7 @@
               <a:buNone/>
             </a:pPr>
             <a:r>
-              <a:rPr lang="en-US" sz="850" u="sng" dirty="0">
+              <a:rPr lang="en-US" sz="900" u="sng" dirty="0">
                 <a:solidFill>
                   <a:srgbClr val="1D6B62"/>
                 </a:solidFill>
@@ -6923,7 +6923,7 @@
               <a:buNone/>
             </a:pPr>
             <a:r>
-              <a:rPr lang="en-US" sz="850" dirty="0">
+              <a:rPr lang="en-US" sz="900" dirty="0">
                 <a:solidFill>
                   <a:srgbClr val="D9D2C2"/>
                 </a:solidFill>
@@ -6937,7 +6937,7 @@
               <a:buNone/>
             </a:pPr>
             <a:r>
-              <a:rPr lang="en-US" sz="850" u="sng" dirty="0">
+              <a:rPr lang="en-US" sz="900" u="sng" dirty="0">
                 <a:solidFill>
                   <a:srgbClr val="1D6B62"/>
                 </a:solidFill>
@@ -6959,7 +6959,7 @@
               </a:rPr>
               <a:t>MANNA FoodBank recall workflow</a:t>
             </a:r>
-            <a:endParaRPr lang="en-US" sz="850" dirty="0"/>
+            <a:endParaRPr lang="en-US" sz="900" dirty="0"/>
           </a:p>
         </p:txBody>
       </p:sp>
@@ -7153,7 +7153,7 @@
                 <a:ea typeface="Aptos" pitchFamily="34" charset="-122"/>
                 <a:cs typeface="Aptos" pitchFamily="34" charset="-120"/>
               </a:rPr>
-              <a:t>Current openFDA and FSIS incidents cross a provenance-verified source boundary before the agent joins them to synthetic operations. Zero linked lots or POs means zero exposure and no approval action.</a:t>
+              <a:t>Official incidents cross a provenance-verified source boundary. A disclosed SYN-LIVE trace sample demonstrates matching; untouched-network mode preserves the honest zero-exposure path.</a:t>
             </a:r>
             <a:endParaRPr lang="en-US" sz="1500" dirty="0"/>
           </a:p>
@@ -8140,9 +8140,9 @@
               <a:buNone/>
             </a:pPr>
             <a:r>
-              <a:rPr lang="en-US" sz="830" dirty="0">
-                <a:solidFill>
-                  <a:srgbClr val="78B7A9"/>
+              <a:rPr lang="en-US" sz="900" dirty="0">
+                <a:solidFill>
+                  <a:srgbClr val="D7E7E1"/>
                 </a:solidFill>
                 <a:latin typeface="Aptos" pitchFamily="34" charset="0"/>
                 <a:ea typeface="Aptos" pitchFamily="34" charset="-122"/>
@@ -8150,7 +8150,7 @@
               </a:rPr>
               <a:t>unsupported fields dropped</a:t>
             </a:r>
-            <a:endParaRPr lang="en-US" sz="830" dirty="0"/>
+            <a:endParaRPr lang="en-US" sz="900" dirty="0"/>
           </a:p>
         </p:txBody>
       </p:sp>
@@ -8247,9 +8247,9 @@
               <a:buNone/>
             </a:pPr>
             <a:r>
-              <a:rPr lang="en-US" sz="830" dirty="0">
-                <a:solidFill>
-                  <a:srgbClr val="78B7A9"/>
+              <a:rPr lang="en-US" sz="900" dirty="0">
+                <a:solidFill>
+                  <a:srgbClr val="D7E7E1"/>
                 </a:solidFill>
                 <a:latin typeface="Aptos" pitchFamily="34" charset="0"/>
                 <a:ea typeface="Aptos" pitchFamily="34" charset="-122"/>
@@ -8257,7 +8257,7 @@
               </a:rPr>
               <a:t>confirmed inventory never returns</a:t>
             </a:r>
-            <a:endParaRPr lang="en-US" sz="830" dirty="0"/>
+            <a:endParaRPr lang="en-US" sz="900" dirty="0"/>
           </a:p>
         </p:txBody>
       </p:sp>
@@ -8354,9 +8354,9 @@
               <a:buNone/>
             </a:pPr>
             <a:r>
-              <a:rPr lang="en-US" sz="830" dirty="0">
-                <a:solidFill>
-                  <a:srgbClr val="78B7A9"/>
+              <a:rPr lang="en-US" sz="900" dirty="0">
+                <a:solidFill>
+                  <a:srgbClr val="D7E7E1"/>
                 </a:solidFill>
                 <a:latin typeface="Aptos" pitchFamily="34" charset="0"/>
                 <a:ea typeface="Aptos" pitchFamily="34" charset="-122"/>
@@ -8364,7 +8364,7 @@
               </a:rPr>
               <a:t>warehouse FEFO + PO ETA</a:t>
             </a:r>
-            <a:endParaRPr lang="en-US" sz="830" dirty="0"/>
+            <a:endParaRPr lang="en-US" sz="900" dirty="0"/>
           </a:p>
         </p:txBody>
       </p:sp>
@@ -8461,9 +8461,9 @@
               <a:buNone/>
             </a:pPr>
             <a:r>
-              <a:rPr lang="en-US" sz="830" dirty="0">
-                <a:solidFill>
-                  <a:srgbClr val="78B7A9"/>
+              <a:rPr lang="en-US" sz="900" dirty="0">
+                <a:solidFill>
+                  <a:srgbClr val="D7E7E1"/>
                 </a:solidFill>
                 <a:latin typeface="Aptos" pitchFamily="34" charset="0"/>
                 <a:ea typeface="Aptos" pitchFamily="34" charset="-122"/>
@@ -8471,7 +8471,7 @@
               </a:rPr>
               <a:t>capacity, demand, expiry, cost</a:t>
             </a:r>
-            <a:endParaRPr lang="en-US" sz="830" dirty="0"/>
+            <a:endParaRPr lang="en-US" sz="900" dirty="0"/>
           </a:p>
         </p:txBody>
       </p:sp>
@@ -8568,9 +8568,9 @@
               <a:buNone/>
             </a:pPr>
             <a:r>
-              <a:rPr lang="en-US" sz="830" dirty="0">
-                <a:solidFill>
-                  <a:srgbClr val="78B7A9"/>
+              <a:rPr lang="en-US" sz="900" dirty="0">
+                <a:solidFill>
+                  <a:srgbClr val="D7E7E1"/>
                 </a:solidFill>
                 <a:latin typeface="Aptos" pitchFamily="34" charset="0"/>
                 <a:ea typeface="Aptos" pitchFamily="34" charset="-122"/>
@@ -8578,7 +8578,7 @@
               </a:rPr>
               <a:t>latest, intact, feasible, idempotent</a:t>
             </a:r>
-            <a:endParaRPr lang="en-US" sz="830" dirty="0"/>
+            <a:endParaRPr lang="en-US" sz="900" dirty="0"/>
           </a:p>
         </p:txBody>
       </p:sp>
@@ -9269,7 +9269,7 @@
               <a:buNone/>
             </a:pPr>
             <a:r>
-              <a:rPr lang="en-US" sz="850" dirty="0">
+              <a:rPr lang="en-US" sz="900" dirty="0">
                 <a:solidFill>
                   <a:srgbClr val="61706D"/>
                 </a:solidFill>
@@ -9283,7 +9283,7 @@
               <a:buNone/>
             </a:pPr>
             <a:r>
-              <a:rPr lang="en-US" sz="850" u="sng" dirty="0">
+              <a:rPr lang="en-US" sz="900" u="sng" dirty="0">
                 <a:solidFill>
                   <a:srgbClr val="1D6B62"/>
                 </a:solidFill>
@@ -9309,7 +9309,7 @@
               <a:buNone/>
             </a:pPr>
             <a:r>
-              <a:rPr lang="en-US" sz="850" dirty="0">
+              <a:rPr lang="en-US" sz="900" dirty="0">
                 <a:solidFill>
                   <a:srgbClr val="D9D2C2"/>
                 </a:solidFill>
@@ -9323,7 +9323,7 @@
               <a:buNone/>
             </a:pPr>
             <a:r>
-              <a:rPr lang="en-US" sz="850" u="sng" dirty="0">
+              <a:rPr lang="en-US" sz="900" u="sng" dirty="0">
                 <a:solidFill>
                   <a:srgbClr val="1D6B62"/>
                 </a:solidFill>
@@ -9349,7 +9349,7 @@
               <a:buNone/>
             </a:pPr>
             <a:r>
-              <a:rPr lang="en-US" sz="850" dirty="0">
+              <a:rPr lang="en-US" sz="900" dirty="0">
                 <a:solidFill>
                   <a:srgbClr val="D9D2C2"/>
                 </a:solidFill>
@@ -9363,7 +9363,7 @@
               <a:buNone/>
             </a:pPr>
             <a:r>
-              <a:rPr lang="en-US" sz="850" u="sng" dirty="0">
+              <a:rPr lang="en-US" sz="900" u="sng" dirty="0">
                 <a:solidFill>
                   <a:srgbClr val="1D6B62"/>
                 </a:solidFill>
@@ -9385,7 +9385,7 @@
               </a:rPr>
               <a:t>Approval implementation</a:t>
             </a:r>
-            <a:endParaRPr lang="en-US" sz="850" dirty="0"/>
+            <a:endParaRPr lang="en-US" sz="900" dirty="0"/>
           </a:p>
         </p:txBody>
       </p:sp>
@@ -9579,7 +9579,7 @@
                 <a:ea typeface="Aptos" pitchFamily="34" charset="-122"/>
                 <a:cs typeface="Aptos" pitchFamily="34" charset="-120"/>
               </a:rPr>
-              <a:t>Typed incident facts survive only when a retained source excerpt supports the exact value. Live API incidents use the same contract and can stop honestly at zero exposure.</a:t>
+              <a:t>API facts survive only with retained source support. SYN-LIVE records stay visibly synthetic, while untouched-network mode can stop honestly at zero exposure.</a:t>
             </a:r>
             <a:endParaRPr lang="en-US" sz="1520" dirty="0"/>
           </a:p>
@@ -10987,7 +10987,7 @@
               <a:buNone/>
             </a:pPr>
             <a:r>
-              <a:rPr lang="en-US" sz="850" dirty="0">
+              <a:rPr lang="en-US" sz="900" dirty="0">
                 <a:solidFill>
                   <a:srgbClr val="61706D"/>
                 </a:solidFill>
@@ -11001,7 +11001,7 @@
               <a:buNone/>
             </a:pPr>
             <a:r>
-              <a:rPr lang="en-US" sz="850" u="sng" dirty="0">
+              <a:rPr lang="en-US" sz="900" u="sng" dirty="0">
                 <a:solidFill>
                   <a:srgbClr val="1D6B62"/>
                 </a:solidFill>
@@ -11027,7 +11027,7 @@
               <a:buNone/>
             </a:pPr>
             <a:r>
-              <a:rPr lang="en-US" sz="850" dirty="0">
+              <a:rPr lang="en-US" sz="900" dirty="0">
                 <a:solidFill>
                   <a:srgbClr val="D9D2C2"/>
                 </a:solidFill>
@@ -11041,7 +11041,7 @@
               <a:buNone/>
             </a:pPr>
             <a:r>
-              <a:rPr lang="en-US" sz="850" u="sng" dirty="0">
+              <a:rPr lang="en-US" sz="900" u="sng" dirty="0">
                 <a:solidFill>
                   <a:srgbClr val="1D6B62"/>
                 </a:solidFill>
@@ -11063,7 +11063,7 @@
               </a:rPr>
               <a:t>Extraction verifier</a:t>
             </a:r>
-            <a:endParaRPr lang="en-US" sz="850" dirty="0"/>
+            <a:endParaRPr lang="en-US" sz="900" dirty="0"/>
           </a:p>
         </p:txBody>
       </p:sp>
@@ -12424,7 +12424,7 @@
               <a:buNone/>
             </a:pPr>
             <a:r>
-              <a:rPr lang="en-US" sz="850" dirty="0">
+              <a:rPr lang="en-US" sz="900" dirty="0">
                 <a:solidFill>
                   <a:srgbClr val="61706D"/>
                 </a:solidFill>
@@ -12438,7 +12438,7 @@
               <a:buNone/>
             </a:pPr>
             <a:r>
-              <a:rPr lang="en-US" sz="850" u="sng" dirty="0">
+              <a:rPr lang="en-US" sz="900" u="sng" dirty="0">
                 <a:solidFill>
                   <a:srgbClr val="1D6B62"/>
                 </a:solidFill>
@@ -12464,7 +12464,7 @@
               <a:buNone/>
             </a:pPr>
             <a:r>
-              <a:rPr lang="en-US" sz="850" dirty="0">
+              <a:rPr lang="en-US" sz="900" dirty="0">
                 <a:solidFill>
                   <a:srgbClr val="D9D2C2"/>
                 </a:solidFill>
@@ -12478,7 +12478,7 @@
               <a:buNone/>
             </a:pPr>
             <a:r>
-              <a:rPr lang="en-US" sz="850" u="sng" dirty="0">
+              <a:rPr lang="en-US" sz="900" u="sng" dirty="0">
                 <a:solidFill>
                   <a:srgbClr val="1D6B62"/>
                 </a:solidFill>
@@ -12500,7 +12500,7 @@
               </a:rPr>
               <a:t>Scenario database</a:t>
             </a:r>
-            <a:endParaRPr lang="en-US" sz="850" dirty="0"/>
+            <a:endParaRPr lang="en-US" sz="900" dirty="0"/>
           </a:p>
         </p:txBody>
       </p:sp>
@@ -12888,7 +12888,7 @@
               <a:buNone/>
             </a:pPr>
             <a:r>
-              <a:rPr lang="en-US" sz="1320" b="1" dirty="0">
+              <a:rPr lang="en-US" sz="1000" b="1" dirty="0">
                 <a:solidFill>
                   <a:srgbClr val="132524"/>
                 </a:solidFill>
@@ -12898,7 +12898,7 @@
               </a:rPr>
               <a:t>PLAN-RECOMMENDED-002</a:t>
             </a:r>
-            <a:endParaRPr lang="en-US" sz="1320" dirty="0"/>
+            <a:endParaRPr lang="en-US" sz="1000" dirty="0"/>
           </a:p>
         </p:txBody>
       </p:sp>
@@ -14095,7 +14095,7 @@
             <a:r>
               <a:rPr lang="en-US" sz="1030" dirty="0">
                 <a:solidFill>
-                  <a:srgbClr val="78B7A9"/>
+                  <a:srgbClr val="D7E7E1"/>
                 </a:solidFill>
                 <a:latin typeface="Aptos" pitchFamily="34" charset="0"/>
                 <a:ea typeface="Aptos" pitchFamily="34" charset="-122"/>
@@ -14112,7 +14112,7 @@
             <a:r>
               <a:rPr lang="en-US" sz="1030" dirty="0">
                 <a:solidFill>
-                  <a:srgbClr val="78B7A9"/>
+                  <a:srgbClr val="D7E7E1"/>
                 </a:solidFill>
                 <a:latin typeface="Aptos" pitchFamily="34" charset="0"/>
                 <a:ea typeface="Aptos" pitchFamily="34" charset="-122"/>
@@ -14129,7 +14129,7 @@
             <a:r>
               <a:rPr lang="en-US" sz="1030" dirty="0">
                 <a:solidFill>
-                  <a:srgbClr val="78B7A9"/>
+                  <a:srgbClr val="D7E7E1"/>
                 </a:solidFill>
                 <a:latin typeface="Aptos" pitchFamily="34" charset="0"/>
                 <a:ea typeface="Aptos" pitchFamily="34" charset="-122"/>
@@ -14168,7 +14168,7 @@
               <a:buNone/>
             </a:pPr>
             <a:r>
-              <a:rPr lang="en-US" sz="850" dirty="0">
+              <a:rPr lang="en-US" sz="900" dirty="0">
                 <a:solidFill>
                   <a:srgbClr val="61706D"/>
                 </a:solidFill>
@@ -14182,7 +14182,7 @@
               <a:buNone/>
             </a:pPr>
             <a:r>
-              <a:rPr lang="en-US" sz="850" u="sng" dirty="0">
+              <a:rPr lang="en-US" sz="900" u="sng" dirty="0">
                 <a:solidFill>
                   <a:srgbClr val="1D6B62"/>
                 </a:solidFill>
@@ -14208,7 +14208,7 @@
               <a:buNone/>
             </a:pPr>
             <a:r>
-              <a:rPr lang="en-US" sz="850" dirty="0">
+              <a:rPr lang="en-US" sz="900" dirty="0">
                 <a:solidFill>
                   <a:srgbClr val="D9D2C2"/>
                 </a:solidFill>
@@ -14222,7 +14222,7 @@
               <a:buNone/>
             </a:pPr>
             <a:r>
-              <a:rPr lang="en-US" sz="850" u="sng" dirty="0">
+              <a:rPr lang="en-US" sz="900" u="sng" dirty="0">
                 <a:solidFill>
                   <a:srgbClr val="1D6B62"/>
                 </a:solidFill>
@@ -14244,7 +14244,7 @@
               </a:rPr>
               <a:t>Approval regression tests</a:t>
             </a:r>
-            <a:endParaRPr lang="en-US" sz="850" dirty="0"/>
+            <a:endParaRPr lang="en-US" sz="900" dirty="0"/>
           </a:p>
         </p:txBody>
       </p:sp>
@@ -14695,7 +14695,7 @@
                 <a:ea typeface="Aptos" pitchFamily="34" charset="-122"/>
                 <a:cs typeface="Aptos" pitchFamily="34" charset="-120"/>
               </a:rPr>
-              <a:t>101 tests</a:t>
+              <a:t>107 tests</a:t>
             </a:r>
             <a:endParaRPr lang="en-US" sz="1250" dirty="0"/>
           </a:p>
@@ -15531,7 +15531,7 @@
             <a:r>
               <a:rPr lang="en-US" sz="1250" b="1" dirty="0">
                 <a:solidFill>
-                  <a:srgbClr val="64757A"/>
+                  <a:srgbClr val="132524"/>
                 </a:solidFill>
                 <a:latin typeface="Aptos" pitchFamily="34" charset="0"/>
                 <a:ea typeface="Aptos" pitchFamily="34" charset="-122"/>
@@ -15613,7 +15613,7 @@
             <a:r>
               <a:rPr lang="en-US" sz="1250" b="1" dirty="0">
                 <a:solidFill>
-                  <a:srgbClr val="64757A"/>
+                  <a:srgbClr val="132524"/>
                 </a:solidFill>
                 <a:latin typeface="Aptos" pitchFamily="34" charset="0"/>
                 <a:ea typeface="Aptos" pitchFamily="34" charset="-122"/>
@@ -15695,7 +15695,7 @@
             <a:r>
               <a:rPr lang="en-US" sz="1250" b="1" dirty="0">
                 <a:solidFill>
-                  <a:srgbClr val="64757A"/>
+                  <a:srgbClr val="132524"/>
                 </a:solidFill>
                 <a:latin typeface="Aptos" pitchFamily="34" charset="0"/>
                 <a:ea typeface="Aptos" pitchFamily="34" charset="-122"/>
@@ -15777,7 +15777,7 @@
             <a:r>
               <a:rPr lang="en-US" sz="1250" b="1" dirty="0">
                 <a:solidFill>
-                  <a:srgbClr val="64757A"/>
+                  <a:srgbClr val="132524"/>
                 </a:solidFill>
                 <a:latin typeface="Aptos" pitchFamily="34" charset="0"/>
                 <a:ea typeface="Aptos" pitchFamily="34" charset="-122"/>
@@ -15923,7 +15923,7 @@
               <a:buNone/>
             </a:pPr>
             <a:r>
-              <a:rPr lang="en-US" sz="850" dirty="0">
+              <a:rPr lang="en-US" sz="900" dirty="0">
                 <a:solidFill>
                   <a:srgbClr val="61706D"/>
                 </a:solidFill>
@@ -15937,7 +15937,7 @@
               <a:buNone/>
             </a:pPr>
             <a:r>
-              <a:rPr lang="en-US" sz="850" u="sng" dirty="0">
+              <a:rPr lang="en-US" sz="900" u="sng" dirty="0">
                 <a:solidFill>
                   <a:srgbClr val="1D6B62"/>
                 </a:solidFill>
@@ -15963,7 +15963,7 @@
               <a:buNone/>
             </a:pPr>
             <a:r>
-              <a:rPr lang="en-US" sz="850" dirty="0">
+              <a:rPr lang="en-US" sz="900" dirty="0">
                 <a:solidFill>
                   <a:srgbClr val="D9D2C2"/>
                 </a:solidFill>
@@ -15977,7 +15977,7 @@
               <a:buNone/>
             </a:pPr>
             <a:r>
-              <a:rPr lang="en-US" sz="850" u="sng" dirty="0">
+              <a:rPr lang="en-US" sz="900" u="sng" dirty="0">
                 <a:solidFill>
                   <a:srgbClr val="1D6B62"/>
                 </a:solidFill>
@@ -16003,7 +16003,7 @@
               <a:buNone/>
             </a:pPr>
             <a:r>
-              <a:rPr lang="en-US" sz="850" dirty="0">
+              <a:rPr lang="en-US" sz="900" dirty="0">
                 <a:solidFill>
                   <a:srgbClr val="D9D2C2"/>
                 </a:solidFill>
@@ -16017,7 +16017,7 @@
               <a:buNone/>
             </a:pPr>
             <a:r>
-              <a:rPr lang="en-US" sz="850" u="sng" dirty="0">
+              <a:rPr lang="en-US" sz="900" u="sng" dirty="0">
                 <a:solidFill>
                   <a:srgbClr val="1D6B62"/>
                 </a:solidFill>
@@ -16039,7 +16039,7 @@
               </a:rPr>
               <a:t>Safety tests</a:t>
             </a:r>
-            <a:endParaRPr lang="en-US" sz="850" dirty="0"/>
+            <a:endParaRPr lang="en-US" sz="900" dirty="0"/>
           </a:p>
         </p:txBody>
       </p:sp>
@@ -16202,7 +16202,7 @@
               <a:buNone/>
             </a:pPr>
             <a:r>
-              <a:rPr lang="en-US" sz="950" b="1" dirty="0">
+              <a:rPr lang="en-US" sz="850" b="1" dirty="0">
                 <a:solidFill>
                   <a:srgbClr val="FFFDF8"/>
                 </a:solidFill>
@@ -16210,9 +16210,9 @@
                 <a:ea typeface="Aptos" pitchFamily="34" charset="-122"/>
                 <a:cs typeface="Aptos" pitchFamily="34" charset="-120"/>
               </a:rPr>
-              <a:t>FF</a:t>
-            </a:r>
-            <a:endParaRPr lang="en-US" sz="950" dirty="0"/>
+              <a:t>FFF</a:t>
+            </a:r>
+            <a:endParaRPr lang="en-US" sz="850" dirty="0"/>
           </a:p>
         </p:txBody>
       </p:sp>
@@ -16492,7 +16492,7 @@
             <a:r>
               <a:rPr lang="en-US" sz="1100" dirty="0">
                 <a:solidFill>
-                  <a:srgbClr val="78B7A9"/>
+                  <a:srgbClr val="D7E7E1"/>
                 </a:solidFill>
                 <a:latin typeface="Aptos" pitchFamily="34" charset="0"/>
                 <a:ea typeface="Aptos" pitchFamily="34" charset="-122"/>
@@ -16640,7 +16640,7 @@
             <a:r>
               <a:rPr lang="en-US" sz="1100" dirty="0">
                 <a:solidFill>
-                  <a:srgbClr val="78B7A9"/>
+                  <a:srgbClr val="D7E7E1"/>
                 </a:solidFill>
                 <a:latin typeface="Aptos" pitchFamily="34" charset="0"/>
                 <a:ea typeface="Aptos" pitchFamily="34" charset="-122"/>
@@ -16788,7 +16788,7 @@
             <a:r>
               <a:rPr lang="en-US" sz="1100" dirty="0">
                 <a:solidFill>
-                  <a:srgbClr val="78B7A9"/>
+                  <a:srgbClr val="D7E7E1"/>
                 </a:solidFill>
                 <a:latin typeface="Aptos" pitchFamily="34" charset="0"/>
                 <a:ea typeface="Aptos" pitchFamily="34" charset="-122"/>
@@ -16996,7 +16996,7 @@
         <p:spPr>
           <a:xfrm>
             <a:off x="8759952" y="4654296"/>
-            <a:ext cx="2331720" cy="475488"/>
+            <a:ext cx="2331720" cy="274320"/>
           </a:xfrm>
           <a:prstGeom prst="rect">
             <a:avLst/>
@@ -17029,31 +17029,7 @@
                   </a:extLst>
                 </a:hlinkClick>
               </a:rPr>
-              <a:t>github.com/Sebastian-Alexis/</a:t>
-            </a:r>
-            <a:endParaRPr lang="en-US" sz="1020" dirty="0"/>
-          </a:p>
-          <a:p>
-            <a:pPr indent="0" marL="0">
-              <a:buNone/>
-            </a:pPr>
-            <a:r>
-              <a:rPr lang="en-US" sz="1020" u="sng" dirty="0">
-                <a:solidFill>
-                  <a:srgbClr val="1D6B62"/>
-                </a:solidFill>
-                <a:latin typeface="Aptos" pitchFamily="34" charset="0"/>
-                <a:ea typeface="Aptos" pitchFamily="34" charset="-122"/>
-                <a:cs typeface="Aptos" pitchFamily="34" charset="-120"/>
-                <a:hlinkClick r:id="rId4" invalidUrl="" action="" tgtFrame="" tooltip="" history="1" highlightClick="0" endSnd="0">
-                  <a:extLst>
-                    <a:ext uri="{A12FA001-AC4F-418D-AE19-62706E023703}">
-                      <ahyp:hlinkClr xmlns:ahyp="http://schemas.microsoft.com/office/drawing/2018/hyperlinkcolor" val="tx"/>
-                    </a:ext>
-                  </a:extLst>
-                </a:hlinkClick>
-              </a:rPr>
-              <a:t>ai_supplychain_foodbank</a:t>
+              <a:t>Open repository on GitHub</a:t>
             </a:r>
             <a:endParaRPr lang="en-US" sz="1020" dirty="0"/>
           </a:p>
@@ -17193,7 +17169,7 @@
               <a:buNone/>
             </a:pPr>
             <a:r>
-              <a:rPr lang="en-US" sz="850" b="1" dirty="0">
+              <a:rPr lang="en-US" sz="900" b="1" dirty="0">
                 <a:solidFill>
                   <a:srgbClr val="78B7A9"/>
                 </a:solidFill>
@@ -17207,7 +17183,7 @@
               <a:buNone/>
             </a:pPr>
             <a:r>
-              <a:rPr lang="en-US" sz="850" u="sng" dirty="0">
+              <a:rPr lang="en-US" sz="900" u="sng" dirty="0">
                 <a:solidFill>
                   <a:srgbClr val="FFFDF8"/>
                 </a:solidFill>
@@ -17228,7 +17204,7 @@
               <a:buNone/>
             </a:pPr>
             <a:r>
-              <a:rPr lang="en-US" sz="850" dirty="0">
+              <a:rPr lang="en-US" sz="900" dirty="0">
                 <a:solidFill>
                   <a:srgbClr val="48635E"/>
                 </a:solidFill>
@@ -17242,7 +17218,7 @@
               <a:buNone/>
             </a:pPr>
             <a:r>
-              <a:rPr lang="en-US" sz="850" u="sng" dirty="0">
+              <a:rPr lang="en-US" sz="900" u="sng" dirty="0">
                 <a:solidFill>
                   <a:srgbClr val="FFFDF8"/>
                 </a:solidFill>
@@ -17263,7 +17239,7 @@
               <a:buNone/>
             </a:pPr>
             <a:r>
-              <a:rPr lang="en-US" sz="850" dirty="0">
+              <a:rPr lang="en-US" sz="900" dirty="0">
                 <a:solidFill>
                   <a:srgbClr val="48635E"/>
                 </a:solidFill>
@@ -17277,7 +17253,7 @@
               <a:buNone/>
             </a:pPr>
             <a:r>
-              <a:rPr lang="en-US" sz="850" u="sng" dirty="0">
+              <a:rPr lang="en-US" sz="900" u="sng" dirty="0">
                 <a:solidFill>
                   <a:srgbClr val="FFFDF8"/>
                 </a:solidFill>
@@ -17298,7 +17274,7 @@
               <a:buNone/>
             </a:pPr>
             <a:r>
-              <a:rPr lang="en-US" sz="850" dirty="0">
+              <a:rPr lang="en-US" sz="900" dirty="0">
                 <a:solidFill>
                   <a:srgbClr val="48635E"/>
                 </a:solidFill>
@@ -17312,7 +17288,7 @@
               <a:buNone/>
             </a:pPr>
             <a:r>
-              <a:rPr lang="en-US" sz="850" u="sng" dirty="0">
+              <a:rPr lang="en-US" sz="900" u="sng" dirty="0">
                 <a:solidFill>
                   <a:srgbClr val="FFFDF8"/>
                 </a:solidFill>
@@ -17333,7 +17309,7 @@
               <a:buNone/>
             </a:pPr>
             <a:r>
-              <a:rPr lang="en-US" sz="850" dirty="0">
+              <a:rPr lang="en-US" sz="900" dirty="0">
                 <a:solidFill>
                   <a:srgbClr val="48635E"/>
                 </a:solidFill>
@@ -17347,7 +17323,7 @@
               <a:buNone/>
             </a:pPr>
             <a:r>
-              <a:rPr lang="en-US" sz="850" u="sng" dirty="0">
+              <a:rPr lang="en-US" sz="900" u="sng" dirty="0">
                 <a:solidFill>
                   <a:srgbClr val="FFFDF8"/>
                 </a:solidFill>
@@ -17364,7 +17340,7 @@
               </a:rPr>
               <a:t>RI Food Bank</a:t>
             </a:r>
-            <a:endParaRPr lang="en-US" sz="850" dirty="0"/>
+            <a:endParaRPr lang="en-US" sz="900" dirty="0"/>
           </a:p>
         </p:txBody>
       </p:sp>

</xml_diff>